<commit_message>
Show the console in the README and add the consent-gate screenshot
The repository page opened on a wall of prose. It now opens on the batch
run, with the decision trail and the consent gate below it.

The deck listed Network Slice Management, which nothing in the tool
registry calls, and left out Number Verification, which the induction
case does call. The API grid now matches the registry and reads in the
order the agent actually escalates.
</commit_message>
<xml_diff>
--- a/Hazir Pitch Deck.pptx
+++ b/Hazir Pitch Deck.pptx
@@ -3570,7 +3570,7 @@
                 <a:ea typeface="Calibri" pitchFamily="34" charset="-122"/>
                 <a:cs typeface="Calibri" pitchFamily="34" charset="-120"/>
               </a:rPr>
-              <a:t>Week 1 of the prototype phase</a:t>
+              <a:t>Built and submitted</a:t>
             </a:r>
             <a:endParaRPr lang="en-US" sz="1500" dirty="0"/>
           </a:p>
@@ -3612,7 +3612,7 @@
                 <a:ea typeface="Calibri" pitchFamily="34" charset="-122"/>
                 <a:cs typeface="Calibri" pitchFamily="34" charset="-120"/>
               </a:rPr>
-              <a:t>Zone fences, induction consent and the live muster count on Nokia simulator numbers.</a:t>
+              <a:t>Zone fences, induction consent, the muster count, ticket checks, the heat rule and the rescue lane.</a:t>
             </a:r>
             <a:endParaRPr lang="en-US" sz="1300" dirty="0"/>
           </a:p>
@@ -3715,7 +3715,7 @@
                 <a:ea typeface="Calibri" pitchFamily="34" charset="-122"/>
                 <a:cs typeface="Calibri" pitchFamily="34" charset="-120"/>
               </a:rPr>
-              <a:t>Week 2</a:t>
+              <a:t>Next, with an operator key</a:t>
             </a:r>
             <a:endParaRPr lang="en-US" sz="1500" dirty="0"/>
           </a:p>
@@ -3757,7 +3757,7 @@
                 <a:ea typeface="Calibri" pitchFamily="34" charset="-122"/>
                 <a:cs typeface="Calibri" pitchFamily="34" charset="-120"/>
               </a:rPr>
-              <a:t>Ticket checks per zone, the heat rule, the silent line search list and the reserved lane for the team.</a:t>
+              <a:t>The same agent against live Nokia Network as Code, replacing simulator answers one API at a time.</a:t>
             </a:r>
             <a:endParaRPr lang="en-US" sz="1300" dirty="0"/>
           </a:p>
@@ -7502,7 +7502,7 @@
                 <a:ea typeface="Calibri" pitchFamily="34" charset="-122"/>
                 <a:cs typeface="Calibri" pitchFamily="34" charset="-120"/>
               </a:rPr>
-              <a:t>Geofencing</a:t>
+              <a:t>Number Verification</a:t>
             </a:r>
             <a:endParaRPr lang="en-US" sz="1450" dirty="0"/>
           </a:p>
@@ -7544,7 +7544,7 @@
                 <a:ea typeface="Calibri" pitchFamily="34" charset="-122"/>
                 <a:cs typeface="Calibri" pitchFamily="34" charset="-120"/>
               </a:rPr>
-              <a:t>One subscription per line and work zone, created at induction.</a:t>
+              <a:t>Confirms the company line is the one in the worker's hand.</a:t>
             </a:r>
             <a:endParaRPr lang="en-US" sz="1250" dirty="0"/>
           </a:p>
@@ -7635,7 +7635,7 @@
                 <a:ea typeface="Calibri" pitchFamily="34" charset="-122"/>
                 <a:cs typeface="Calibri" pitchFamily="34" charset="-120"/>
               </a:rPr>
-              <a:t>Location Verification</a:t>
+              <a:t>Geofencing</a:t>
             </a:r>
             <a:endParaRPr lang="en-US" sz="1450" dirty="0"/>
           </a:p>
@@ -7677,7 +7677,7 @@
                 <a:ea typeface="Calibri" pitchFamily="34" charset="-122"/>
                 <a:cs typeface="Calibri" pitchFamily="34" charset="-120"/>
               </a:rPr>
-              <a:t>A yes or no about a zone. No track of the man is ever built.</a:t>
+              <a:t>One subscription per line and work zone, created at induction.</a:t>
             </a:r>
             <a:endParaRPr lang="en-US" sz="1250" dirty="0"/>
           </a:p>
@@ -7768,7 +7768,7 @@
                 <a:ea typeface="Calibri" pitchFamily="34" charset="-122"/>
                 <a:cs typeface="Calibri" pitchFamily="34" charset="-120"/>
               </a:rPr>
-              <a:t>Location Retrieval</a:t>
+              <a:t>Location Verification</a:t>
             </a:r>
             <a:endParaRPr lang="en-US" sz="1450" dirty="0"/>
           </a:p>
@@ -7810,7 +7810,7 @@
                 <a:ea typeface="Calibri" pitchFamily="34" charset="-122"/>
                 <a:cs typeface="Calibri" pitchFamily="34" charset="-120"/>
               </a:rPr>
-              <a:t>A last known area, only for a line that stayed silent in an alert.</a:t>
+              <a:t>A yes or no about a zone. No track of the man is ever built.</a:t>
             </a:r>
             <a:endParaRPr lang="en-US" sz="1250" dirty="0"/>
           </a:p>
@@ -8034,7 +8034,7 @@
                 <a:ea typeface="Calibri" pitchFamily="34" charset="-122"/>
                 <a:cs typeface="Calibri" pitchFamily="34" charset="-120"/>
               </a:rPr>
-              <a:t>Congestion Insights</a:t>
+              <a:t>Location Retrieval</a:t>
             </a:r>
             <a:endParaRPr lang="en-US" sz="1450" dirty="0"/>
           </a:p>
@@ -8076,7 +8076,7 @@
                 <a:ea typeface="Calibri" pitchFamily="34" charset="-122"/>
                 <a:cs typeface="Calibri" pitchFamily="34" charset="-120"/>
               </a:rPr>
-              <a:t>Shows how full the cell is once every phone on site starts calling.</a:t>
+              <a:t>A last known area, only for a line that stayed silent in an alert.</a:t>
             </a:r>
             <a:endParaRPr lang="en-US" sz="1250" dirty="0"/>
           </a:p>
@@ -8167,7 +8167,7 @@
                 <a:ea typeface="Calibri" pitchFamily="34" charset="-122"/>
                 <a:cs typeface="Calibri" pitchFamily="34" charset="-120"/>
               </a:rPr>
-              <a:t>Quality on Demand</a:t>
+              <a:t>Congestion Insights</a:t>
             </a:r>
             <a:endParaRPr lang="en-US" sz="1450" dirty="0"/>
           </a:p>
@@ -8209,7 +8209,7 @@
                 <a:ea typeface="Calibri" pitchFamily="34" charset="-122"/>
                 <a:cs typeface="Calibri" pitchFamily="34" charset="-120"/>
               </a:rPr>
-              <a:t>Books stable video for the medic and the incident commander.</a:t>
+              <a:t>Shows how full the cell is once every phone on site starts calling.</a:t>
             </a:r>
             <a:endParaRPr lang="en-US" sz="1250" dirty="0"/>
           </a:p>
@@ -8300,7 +8300,7 @@
                 <a:ea typeface="Calibri" pitchFamily="34" charset="-122"/>
                 <a:cs typeface="Calibri" pitchFamily="34" charset="-120"/>
               </a:rPr>
-              <a:t>Network Slice Management</a:t>
+              <a:t>Slice Device Attachment</a:t>
             </a:r>
             <a:endParaRPr lang="en-US" sz="1450" dirty="0"/>
           </a:p>
@@ -8342,7 +8342,7 @@
                 <a:ea typeface="Calibri" pitchFamily="34" charset="-122"/>
                 <a:cs typeface="Calibri" pitchFamily="34" charset="-120"/>
               </a:rPr>
-              <a:t>Holds a private lane for the emergency team during a large event.</a:t>
+              <a:t>Puts the rescue team's phones and drones on a private lane in seconds.</a:t>
             </a:r>
             <a:endParaRPr lang="en-US" sz="1250" dirty="0"/>
           </a:p>
@@ -8433,7 +8433,7 @@
                 <a:ea typeface="Calibri" pitchFamily="34" charset="-122"/>
                 <a:cs typeface="Calibri" pitchFamily="34" charset="-120"/>
               </a:rPr>
-              <a:t>Slice Device Attachment</a:t>
+              <a:t>Quality on Demand</a:t>
             </a:r>
             <a:endParaRPr lang="en-US" sz="1450" dirty="0"/>
           </a:p>
@@ -8475,7 +8475,7 @@
                 <a:ea typeface="Calibri" pitchFamily="34" charset="-122"/>
                 <a:cs typeface="Calibri" pitchFamily="34" charset="-120"/>
               </a:rPr>
-              <a:t>Puts the right team phones and drones on that lane in seconds.</a:t>
+              <a:t>Books stable video for the medic and the incident commander.</a:t>
             </a:r>
             <a:endParaRPr lang="en-US" sz="1250" dirty="0"/>
           </a:p>
@@ -8514,7 +8514,7 @@
                 <a:ea typeface="Calibri" pitchFamily="34" charset="-122"/>
                 <a:cs typeface="Calibri" pitchFamily="34" charset="-120"/>
               </a:rPr>
-              <a:t>All eight are wired in the working prototype, network slicing included. 8 scenarios, all reaching the outcome they claim, at 77.5% less than calling every check.</a:t>
+              <a:t>All eight are wired in the working prototype and called by the shipped scenarios. Eight scenarios, each reaching the outcome it claims, spending one to six calls a case and 77.5% less than calling every check.</a:t>
             </a:r>
             <a:endParaRPr lang="en-US" sz="1100" dirty="0"/>
           </a:p>

</xml_diff>